<commit_message>
Add Pinecone RAG matching and Apps Script automation
</commit_message>
<xml_diff>
--- a/AI_Resume_Analyzer_Presentation.pptx
+++ b/AI_Resume_Analyzer_Presentation.pptx
@@ -14,6 +14,8 @@
     <p:sldId id="265" r:id="rId10"/>
     <p:sldId id="266" r:id="rId11"/>
     <p:sldId id="267" r:id="rId12"/>
+    <p:sldId id="268" r:id="rId13"/>
+    <p:sldId id="269" r:id="rId14"/>
   </p:sldIdLst>
   <p:sldSz cx="10000000" cy="5625000" type="wide"/>
   <p:notesSz cx="6858000" cy="9144000"/>
@@ -173,7 +175,7 @@
                   <a:srgbClr val="0F172A"/>
                 </a:solidFill>
               </a:rPr>
-              <a:t>Results</a:t>
+              <a:t>Scoring Logic</a:t>
             </a:r>
           </a:p>
         </p:txBody>
@@ -196,7 +198,7 @@
           <a:p>
             <a:r>
               <a:rPr lang="en-US" sz="2600"/>
-              <a:t>ATS score out of 100</a:t>
+              <a:t>Skill match: 30 percent</a:t>
             </a:r>
           </a:p>
         </p:txBody>
@@ -219,7 +221,7 @@
           <a:p>
             <a:r>
               <a:rPr lang="en-US" sz="2600"/>
-              <a:t>Strengths and weaknesses</a:t>
+              <a:t>Semantic similarity: 25 percent</a:t>
             </a:r>
           </a:p>
         </p:txBody>
@@ -242,7 +244,7 @@
           <a:p>
             <a:r>
               <a:rPr lang="en-US" sz="2600"/>
-              <a:t>Missing job skills</a:t>
+              <a:t>Section completeness: 20 percent</a:t>
             </a:r>
           </a:p>
         </p:txBody>
@@ -265,7 +267,7 @@
           <a:p>
             <a:r>
               <a:rPr lang="en-US" sz="2600"/>
-              <a:t>Candidate expiry date</a:t>
+              <a:t>Keyword overlap: 15 percent</a:t>
             </a:r>
           </a:p>
         </p:txBody>
@@ -288,30 +290,7 @@
           <a:p>
             <a:r>
               <a:rPr lang="en-US" sz="2600"/>
-              <a:t>Company requirement context</a:t>
-            </a:r>
-          </a:p>
-        </p:txBody>
-      </p:sp>
-      <p:sp>
-        <p:nvSpPr>
-          <p:cNvPr id="4600000" name="Bullet"/>
-          <p:cNvSpPr/>
-          <p:nvPr/>
-        </p:nvSpPr>
-        <p:spPr>
-          <a:xfrm>
-            <a:off x="850000" y="4600000"/>
-            <a:ext cx="7600000" cy="420000"/>
-          </a:xfrm>
-        </p:spPr>
-        <p:txBody>
-          <a:bodyPr/>
-          <a:lstStyle/>
-          <a:p>
-            <a:r>
-              <a:rPr lang="en-US" sz="2600"/>
-              <a:t>Best-fit role shortlist</a:t>
+              <a:t>Contact and length quality: 10 percent</a:t>
             </a:r>
           </a:p>
         </p:txBody>
@@ -371,7 +350,7 @@
                   <a:srgbClr val="0F172A"/>
                 </a:solidFill>
               </a:rPr>
-              <a:t>Deployment</a:t>
+              <a:t>User Interface</a:t>
             </a:r>
           </a:p>
         </p:txBody>
@@ -394,7 +373,7 @@
           <a:p>
             <a:r>
               <a:rPr lang="en-US" sz="2600"/>
-              <a:t>Dashboard deploys on Streamlit Cloud.</a:t>
+              <a:t>Single resume analyzer</a:t>
             </a:r>
           </a:p>
         </p:txBody>
@@ -417,7 +396,7 @@
           <a:p>
             <a:r>
               <a:rPr lang="en-US" sz="2600"/>
-              <a:t>Webhook API deploys on Render.</a:t>
+              <a:t>Company candidate intake</a:t>
             </a:r>
           </a:p>
         </p:txBody>
@@ -440,7 +419,7 @@
           <a:p>
             <a:r>
               <a:rPr lang="en-US" sz="2600"/>
-              <a:t>Apps Script connects Google Form to API.</a:t>
+              <a:t>Company growth timeline</a:t>
             </a:r>
           </a:p>
         </p:txBody>
@@ -463,7 +442,53 @@
           <a:p>
             <a:r>
               <a:rPr lang="en-US" sz="2600"/>
-              <a:t>Pinecone is optional with local fallback.</a:t>
+              <a:t>Active candidate database</a:t>
+            </a:r>
+          </a:p>
+        </p:txBody>
+      </p:sp>
+      <p:sp>
+        <p:nvSpPr>
+          <p:cNvPr id="4040000" name="Bullet"/>
+          <p:cNvSpPr/>
+          <p:nvPr/>
+        </p:nvSpPr>
+        <p:spPr>
+          <a:xfrm>
+            <a:off x="850000" y="4040000"/>
+            <a:ext cx="7600000" cy="420000"/>
+          </a:xfrm>
+        </p:spPr>
+        <p:txBody>
+          <a:bodyPr/>
+          <a:lstStyle/>
+          <a:p>
+            <a:r>
+              <a:rPr lang="en-US" sz="2600"/>
+              <a:t>Role matching dashboard</a:t>
+            </a:r>
+          </a:p>
+        </p:txBody>
+      </p:sp>
+      <p:sp>
+        <p:nvSpPr>
+          <p:cNvPr id="4600000" name="Bullet"/>
+          <p:cNvSpPr/>
+          <p:nvPr/>
+        </p:nvSpPr>
+        <p:spPr>
+          <a:xfrm>
+            <a:off x="850000" y="4600000"/>
+            <a:ext cx="7600000" cy="420000"/>
+          </a:xfrm>
+        </p:spPr>
+        <p:txBody>
+          <a:bodyPr/>
+          <a:lstStyle/>
+          <a:p>
+            <a:r>
+              <a:rPr lang="en-US" sz="2600"/>
+              <a:t>CSV shortlist export</a:t>
             </a:r>
           </a:p>
         </p:txBody>
@@ -523,6 +548,356 @@
                   <a:srgbClr val="0F172A"/>
                 </a:solidFill>
               </a:rPr>
+              <a:t>Results</a:t>
+            </a:r>
+          </a:p>
+        </p:txBody>
+      </p:sp>
+      <p:sp>
+        <p:nvSpPr>
+          <p:cNvPr id="1800000" name="Bullet"/>
+          <p:cNvSpPr/>
+          <p:nvPr/>
+        </p:nvSpPr>
+        <p:spPr>
+          <a:xfrm>
+            <a:off x="850000" y="1800000"/>
+            <a:ext cx="7600000" cy="420000"/>
+          </a:xfrm>
+        </p:spPr>
+        <p:txBody>
+          <a:bodyPr/>
+          <a:lstStyle/>
+          <a:p>
+            <a:r>
+              <a:rPr lang="en-US" sz="2600"/>
+              <a:t>ATS score out of 100</a:t>
+            </a:r>
+          </a:p>
+        </p:txBody>
+      </p:sp>
+      <p:sp>
+        <p:nvSpPr>
+          <p:cNvPr id="2360000" name="Bullet"/>
+          <p:cNvSpPr/>
+          <p:nvPr/>
+        </p:nvSpPr>
+        <p:spPr>
+          <a:xfrm>
+            <a:off x="850000" y="2360000"/>
+            <a:ext cx="7600000" cy="420000"/>
+          </a:xfrm>
+        </p:spPr>
+        <p:txBody>
+          <a:bodyPr/>
+          <a:lstStyle/>
+          <a:p>
+            <a:r>
+              <a:rPr lang="en-US" sz="2600"/>
+              <a:t>Strengths and weaknesses</a:t>
+            </a:r>
+          </a:p>
+        </p:txBody>
+      </p:sp>
+      <p:sp>
+        <p:nvSpPr>
+          <p:cNvPr id="2920000" name="Bullet"/>
+          <p:cNvSpPr/>
+          <p:nvPr/>
+        </p:nvSpPr>
+        <p:spPr>
+          <a:xfrm>
+            <a:off x="850000" y="2920000"/>
+            <a:ext cx="7600000" cy="420000"/>
+          </a:xfrm>
+        </p:spPr>
+        <p:txBody>
+          <a:bodyPr/>
+          <a:lstStyle/>
+          <a:p>
+            <a:r>
+              <a:rPr lang="en-US" sz="2600"/>
+              <a:t>Missing job skills</a:t>
+            </a:r>
+          </a:p>
+        </p:txBody>
+      </p:sp>
+      <p:sp>
+        <p:nvSpPr>
+          <p:cNvPr id="3480000" name="Bullet"/>
+          <p:cNvSpPr/>
+          <p:nvPr/>
+        </p:nvSpPr>
+        <p:spPr>
+          <a:xfrm>
+            <a:off x="850000" y="3480000"/>
+            <a:ext cx="7600000" cy="420000"/>
+          </a:xfrm>
+        </p:spPr>
+        <p:txBody>
+          <a:bodyPr/>
+          <a:lstStyle/>
+          <a:p>
+            <a:r>
+              <a:rPr lang="en-US" sz="2600"/>
+              <a:t>Candidate expiry date</a:t>
+            </a:r>
+          </a:p>
+        </p:txBody>
+      </p:sp>
+      <p:sp>
+        <p:nvSpPr>
+          <p:cNvPr id="4040000" name="Bullet"/>
+          <p:cNvSpPr/>
+          <p:nvPr/>
+        </p:nvSpPr>
+        <p:spPr>
+          <a:xfrm>
+            <a:off x="850000" y="4040000"/>
+            <a:ext cx="7600000" cy="420000"/>
+          </a:xfrm>
+        </p:spPr>
+        <p:txBody>
+          <a:bodyPr/>
+          <a:lstStyle/>
+          <a:p>
+            <a:r>
+              <a:rPr lang="en-US" sz="2600"/>
+              <a:t>Company requirement context</a:t>
+            </a:r>
+          </a:p>
+        </p:txBody>
+      </p:sp>
+      <p:sp>
+        <p:nvSpPr>
+          <p:cNvPr id="4600000" name="Bullet"/>
+          <p:cNvSpPr/>
+          <p:nvPr/>
+        </p:nvSpPr>
+        <p:spPr>
+          <a:xfrm>
+            <a:off x="850000" y="4600000"/>
+            <a:ext cx="7600000" cy="420000"/>
+          </a:xfrm>
+        </p:spPr>
+        <p:txBody>
+          <a:bodyPr/>
+          <a:lstStyle/>
+          <a:p>
+            <a:r>
+              <a:rPr lang="en-US" sz="2600"/>
+              <a:t>Best-fit role shortlist</a:t>
+            </a:r>
+          </a:p>
+        </p:txBody>
+      </p:sp>
+    </p:spTree>
+  </p:cSld>
+  <p:clrMapOvr>
+    <a:masterClrMapping/>
+  </p:clrMapOvr>
+</p:sld>
+</file>
+
+<file path=ppt/slides/slide13.xml><?xml version="1.0" encoding="utf-8"?>
+<p:sld xmlns:a="http://schemas.openxmlformats.org/drawingml/2006/main" xmlns:r="http://schemas.openxmlformats.org/officeDocument/2006/relationships" xmlns:p="http://schemas.openxmlformats.org/presentationml/2006/main">
+  <p:cSld>
+    <p:bg>
+      <p:bgPr>
+        <a:solidFill>
+          <a:srgbClr val="F8FAFC"/>
+        </a:solidFill>
+        <a:effectLst/>
+      </p:bgPr>
+    </p:bg>
+    <p:spTree>
+      <p:nvGrpSpPr>
+        <p:cNvPr id="1" name=""/>
+        <p:cNvGrpSpPr/>
+        <p:nvPr/>
+      </p:nvGrpSpPr>
+      <p:grpSpPr>
+        <a:xfrm>
+          <a:off x="0" y="0"/>
+          <a:ext cx="0" cy="0"/>
+          <a:chOff x="0" y="0"/>
+          <a:chExt cx="0" cy="0"/>
+        </a:xfrm>
+      </p:grpSpPr>
+      <p:sp>
+        <p:nvSpPr>
+          <p:cNvPr id="2" name="Title"/>
+          <p:cNvSpPr/>
+          <p:nvPr/>
+        </p:nvSpPr>
+        <p:spPr>
+          <a:xfrm>
+            <a:off x="650000" y="520000"/>
+            <a:ext cx="8200000" cy="850000"/>
+          </a:xfrm>
+        </p:spPr>
+        <p:txBody>
+          <a:bodyPr/>
+          <a:lstStyle/>
+          <a:p>
+            <a:r>
+              <a:rPr lang="en-US" sz="4200" b="1">
+                <a:solidFill>
+                  <a:srgbClr val="0F172A"/>
+                </a:solidFill>
+              </a:rPr>
+              <a:t>Deployment</a:t>
+            </a:r>
+          </a:p>
+        </p:txBody>
+      </p:sp>
+      <p:sp>
+        <p:nvSpPr>
+          <p:cNvPr id="1800000" name="Bullet"/>
+          <p:cNvSpPr/>
+          <p:nvPr/>
+        </p:nvSpPr>
+        <p:spPr>
+          <a:xfrm>
+            <a:off x="850000" y="1800000"/>
+            <a:ext cx="7600000" cy="420000"/>
+          </a:xfrm>
+        </p:spPr>
+        <p:txBody>
+          <a:bodyPr/>
+          <a:lstStyle/>
+          <a:p>
+            <a:r>
+              <a:rPr lang="en-US" sz="2600"/>
+              <a:t>Dashboard deploys on Streamlit Cloud.</a:t>
+            </a:r>
+          </a:p>
+        </p:txBody>
+      </p:sp>
+      <p:sp>
+        <p:nvSpPr>
+          <p:cNvPr id="2360000" name="Bullet"/>
+          <p:cNvSpPr/>
+          <p:nvPr/>
+        </p:nvSpPr>
+        <p:spPr>
+          <a:xfrm>
+            <a:off x="850000" y="2360000"/>
+            <a:ext cx="7600000" cy="420000"/>
+          </a:xfrm>
+        </p:spPr>
+        <p:txBody>
+          <a:bodyPr/>
+          <a:lstStyle/>
+          <a:p>
+            <a:r>
+              <a:rPr lang="en-US" sz="2600"/>
+              <a:t>Webhook API deploys on Render.</a:t>
+            </a:r>
+          </a:p>
+        </p:txBody>
+      </p:sp>
+      <p:sp>
+        <p:nvSpPr>
+          <p:cNvPr id="2920000" name="Bullet"/>
+          <p:cNvSpPr/>
+          <p:nvPr/>
+        </p:nvSpPr>
+        <p:spPr>
+          <a:xfrm>
+            <a:off x="850000" y="2920000"/>
+            <a:ext cx="7600000" cy="420000"/>
+          </a:xfrm>
+        </p:spPr>
+        <p:txBody>
+          <a:bodyPr/>
+          <a:lstStyle/>
+          <a:p>
+            <a:r>
+              <a:rPr lang="en-US" sz="2600"/>
+              <a:t>Apps Script connects Google Form to API.</a:t>
+            </a:r>
+          </a:p>
+        </p:txBody>
+      </p:sp>
+      <p:sp>
+        <p:nvSpPr>
+          <p:cNvPr id="3480000" name="Bullet"/>
+          <p:cNvSpPr/>
+          <p:nvPr/>
+        </p:nvSpPr>
+        <p:spPr>
+          <a:xfrm>
+            <a:off x="850000" y="3480000"/>
+            <a:ext cx="7600000" cy="420000"/>
+          </a:xfrm>
+        </p:spPr>
+        <p:txBody>
+          <a:bodyPr/>
+          <a:lstStyle/>
+          <a:p>
+            <a:r>
+              <a:rPr lang="en-US" sz="2600"/>
+              <a:t>Pinecone is optional with local fallback.</a:t>
+            </a:r>
+          </a:p>
+        </p:txBody>
+      </p:sp>
+    </p:spTree>
+  </p:cSld>
+  <p:clrMapOvr>
+    <a:masterClrMapping/>
+  </p:clrMapOvr>
+</p:sld>
+</file>
+
+<file path=ppt/slides/slide14.xml><?xml version="1.0" encoding="utf-8"?>
+<p:sld xmlns:a="http://schemas.openxmlformats.org/drawingml/2006/main" xmlns:r="http://schemas.openxmlformats.org/officeDocument/2006/relationships" xmlns:p="http://schemas.openxmlformats.org/presentationml/2006/main">
+  <p:cSld>
+    <p:bg>
+      <p:bgPr>
+        <a:solidFill>
+          <a:srgbClr val="F8FAFC"/>
+        </a:solidFill>
+        <a:effectLst/>
+      </p:bgPr>
+    </p:bg>
+    <p:spTree>
+      <p:nvGrpSpPr>
+        <p:cNvPr id="1" name=""/>
+        <p:cNvGrpSpPr/>
+        <p:nvPr/>
+      </p:nvGrpSpPr>
+      <p:grpSpPr>
+        <a:xfrm>
+          <a:off x="0" y="0"/>
+          <a:ext cx="0" cy="0"/>
+          <a:chOff x="0" y="0"/>
+          <a:chExt cx="0" cy="0"/>
+        </a:xfrm>
+      </p:grpSpPr>
+      <p:sp>
+        <p:nvSpPr>
+          <p:cNvPr id="2" name="Title"/>
+          <p:cNvSpPr/>
+          <p:nvPr/>
+        </p:nvSpPr>
+        <p:spPr>
+          <a:xfrm>
+            <a:off x="650000" y="520000"/>
+            <a:ext cx="8200000" cy="850000"/>
+          </a:xfrm>
+        </p:spPr>
+        <p:txBody>
+          <a:bodyPr/>
+          <a:lstStyle/>
+          <a:p>
+            <a:r>
+              <a:rPr lang="en-US" sz="4200" b="1">
+                <a:solidFill>
+                  <a:srgbClr val="0F172A"/>
+                </a:solidFill>
+              </a:rPr>
               <a:t>Conclusion</a:t>
             </a:r>
           </a:p>
@@ -1550,7 +1925,7 @@
           <a:p>
             <a:r>
               <a:rPr lang="en-US" sz="2600"/>
-              <a:t>Role matching can use both candidate data and company context.</a:t>
+              <a:t>Role matching uses candidate data and retrieved company documents.</a:t>
             </a:r>
           </a:p>
         </p:txBody>
@@ -1610,7 +1985,7 @@
                   <a:srgbClr val="0F172A"/>
                 </a:solidFill>
               </a:rPr>
-              <a:t>Scoring Logic</a:t>
+              <a:t>RAG Flow</a:t>
             </a:r>
           </a:p>
         </p:txBody>
@@ -1633,7 +2008,7 @@
           <a:p>
             <a:r>
               <a:rPr lang="en-US" sz="2600"/>
-              <a:t>Skill match: 30 percent</a:t>
+              <a:t>Store company documents and resumes as vectors in Pinecone.</a:t>
             </a:r>
           </a:p>
         </p:txBody>
@@ -1656,7 +2031,7 @@
           <a:p>
             <a:r>
               <a:rPr lang="en-US" sz="2600"/>
-              <a:t>Semantic similarity: 25 percent</a:t>
+              <a:t>Retrieve relevant company context for a new requirement.</a:t>
             </a:r>
           </a:p>
         </p:txBody>
@@ -1679,7 +2054,7 @@
           <a:p>
             <a:r>
               <a:rPr lang="en-US" sz="2600"/>
-              <a:t>Section completeness: 20 percent</a:t>
+              <a:t>Augment the requirement with retrieved context.</a:t>
             </a:r>
           </a:p>
         </p:txBody>
@@ -1702,7 +2077,7 @@
           <a:p>
             <a:r>
               <a:rPr lang="en-US" sz="2600"/>
-              <a:t>Keyword overlap: 15 percent</a:t>
+              <a:t>Retrieve and rank active candidate resumes.</a:t>
             </a:r>
           </a:p>
         </p:txBody>
@@ -1725,7 +2100,7 @@
           <a:p>
             <a:r>
               <a:rPr lang="en-US" sz="2600"/>
-              <a:t>Contact and length quality: 10 percent</a:t>
+              <a:t>Generate an explainable recommendation.</a:t>
             </a:r>
           </a:p>
         </p:txBody>
@@ -1785,7 +2160,7 @@
                   <a:srgbClr val="0F172A"/>
                 </a:solidFill>
               </a:rPr>
-              <a:t>User Interface</a:t>
+              <a:t>Apps Script Automation</a:t>
             </a:r>
           </a:p>
         </p:txBody>
@@ -1808,7 +2183,7 @@
           <a:p>
             <a:r>
               <a:rPr lang="en-US" sz="2600"/>
-              <a:t>Single resume analyzer</a:t>
+              <a:t>Candidate form sends resumes to the API.</a:t>
             </a:r>
           </a:p>
         </p:txBody>
@@ -1831,7 +2206,7 @@
           <a:p>
             <a:r>
               <a:rPr lang="en-US" sz="2600"/>
-              <a:t>Company candidate intake</a:t>
+              <a:t>Company form sends requirements to the API.</a:t>
             </a:r>
           </a:p>
         </p:txBody>
@@ -1854,7 +2229,7 @@
           <a:p>
             <a:r>
               <a:rPr lang="en-US" sz="2600"/>
-              <a:t>Company growth timeline</a:t>
+              <a:t>Google Sheets menu calls /rag-match.</a:t>
             </a:r>
           </a:p>
         </p:txBody>
@@ -1877,53 +2252,7 @@
           <a:p>
             <a:r>
               <a:rPr lang="en-US" sz="2600"/>
-              <a:t>Active candidate database</a:t>
-            </a:r>
-          </a:p>
-        </p:txBody>
-      </p:sp>
-      <p:sp>
-        <p:nvSpPr>
-          <p:cNvPr id="4040000" name="Bullet"/>
-          <p:cNvSpPr/>
-          <p:nvPr/>
-        </p:nvSpPr>
-        <p:spPr>
-          <a:xfrm>
-            <a:off x="850000" y="4040000"/>
-            <a:ext cx="7600000" cy="420000"/>
-          </a:xfrm>
-        </p:spPr>
-        <p:txBody>
-          <a:bodyPr/>
-          <a:lstStyle/>
-          <a:p>
-            <a:r>
-              <a:rPr lang="en-US" sz="2600"/>
-              <a:t>Role matching dashboard</a:t>
-            </a:r>
-          </a:p>
-        </p:txBody>
-      </p:sp>
-      <p:sp>
-        <p:nvSpPr>
-          <p:cNvPr id="4600000" name="Bullet"/>
-          <p:cNvSpPr/>
-          <p:nvPr/>
-        </p:nvSpPr>
-        <p:spPr>
-          <a:xfrm>
-            <a:off x="850000" y="4600000"/>
-            <a:ext cx="7600000" cy="420000"/>
-          </a:xfrm>
-        </p:spPr>
-        <p:txBody>
-          <a:bodyPr/>
-          <a:lstStyle/>
-          <a:p>
-            <a:r>
-              <a:rPr lang="en-US" sz="2600"/>
-              <a:t>CSV shortlist export</a:t>
+              <a:t>Sheet receives candidate, potential, score, and recommendation.</a:t>
             </a:r>
           </a:p>
         </p:txBody>

</xml_diff>